<commit_message>
docs(legal): record Monsha'at's answers on capital and the profile deck
Minimum capital 5,000 SAR, set by the applicant in SAR or USD; support
letter amendable later; deposit question belongs to MoC. The profile
deck must be PowerPoint and cover overview, services, main activities
and target sectors — mapped slide by slide, and the activity codes now
appear on the project slide.

Co-Authored-By: Claude Fable 5.1 <noreply@anthropic.com>
Claude-Session: https://claude.ai/code/session_01D3UPL4Xh35wSLmj3NFHRuL
</commit_message>
<xml_diff>
--- a/ma3rifah-ai/docs/legal/badiha-license-deck.pptx
+++ b/ma3rifah-ai/docs/legal/badiha-license-deck.pptx
@@ -5691,7 +5691,7 @@
         <p:spPr>
           <a:xfrm>
             <a:off x="4023360" y="1325880"/>
-            <a:ext cx="4572000" cy="3291840"/>
+            <a:ext cx="4572000" cy="3383280"/>
           </a:xfrm>
           <a:prstGeom prst="rect">
             <a:avLst/>
@@ -5705,12 +5705,12 @@
           <a:p>
             <a:pPr rtl="1" algn="r" indent="0" marL="0">
               <a:lnSpc>
-                <a:spcPct val="120000"/>
+                <a:spcPct val="118000"/>
               </a:lnSpc>
               <a:buNone/>
             </a:pPr>
             <a:r>
-              <a:rPr lang="ar-SA" altLang="en-US" sz="1200" dirty="0">
+              <a:rPr lang="ar-SA" altLang="en-US" sz="1150" dirty="0">
                 <a:solidFill>
                   <a:srgbClr val="1B2330"/>
                 </a:solidFill>
@@ -5720,26 +5720,26 @@
               </a:rPr>
               <a:t>بديهة منصة سعودية تعمل في الإنتاج اليوم. ترفع الشركة لوائحها وسياساتها وأدلة إجراءاتها، فيسأل موظفوها بالعربية ويحصلون على إجابات مبنية على تلك المستندات وحدها، مع اسم المستند ورقم الصفحة تحت كل إجابة.</a:t>
             </a:r>
-            <a:endParaRPr lang="ar-SA" sz="1200" dirty="0"/>
+            <a:endParaRPr lang="ar-SA" sz="1150" dirty="0"/>
           </a:p>
           <a:p>
             <a:pPr rtl="1" algn="r" indent="0" marL="0">
               <a:lnSpc>
-                <a:spcPct val="120000"/>
+                <a:spcPct val="118000"/>
               </a:lnSpc>
               <a:buNone/>
             </a:pPr>
-            <a:endParaRPr lang="ar-SA" sz="1200" dirty="0"/>
+            <a:endParaRPr lang="ar-SA" sz="1150" dirty="0"/>
           </a:p>
           <a:p>
             <a:pPr rtl="1" algn="r" indent="0" marL="0">
               <a:lnSpc>
-                <a:spcPct val="120000"/>
+                <a:spcPct val="118000"/>
               </a:lnSpc>
               <a:buNone/>
             </a:pPr>
             <a:r>
-              <a:rPr lang="ar-SA" altLang="en-US" sz="1200" dirty="0">
+              <a:rPr lang="ar-SA" altLang="en-US" sz="1150" dirty="0">
                 <a:solidFill>
                   <a:srgbClr val="1B2330"/>
                 </a:solidFill>
@@ -5749,26 +5749,26 @@
               </a:rPr>
               <a:t>حين لا يجد النظام جوابًا يقول ذلك صراحةً بدل أن يخترع، ويسجّل السؤال ضمن تقرير فجوات المعرفة الذي يوجّه الإدارة إلى ما ينقص توثيقه.</a:t>
             </a:r>
-            <a:endParaRPr lang="ar-SA" sz="1200" dirty="0"/>
+            <a:endParaRPr lang="ar-SA" sz="1150" dirty="0"/>
           </a:p>
           <a:p>
             <a:pPr rtl="1" algn="r" indent="0" marL="0">
               <a:lnSpc>
-                <a:spcPct val="120000"/>
+                <a:spcPct val="118000"/>
               </a:lnSpc>
               <a:buNone/>
             </a:pPr>
-            <a:endParaRPr lang="ar-SA" sz="1200" dirty="0"/>
+            <a:endParaRPr lang="ar-SA" sz="1150" dirty="0"/>
           </a:p>
           <a:p>
             <a:pPr rtl="1" algn="r" indent="0" marL="0">
               <a:lnSpc>
-                <a:spcPct val="120000"/>
+                <a:spcPct val="118000"/>
               </a:lnSpc>
               <a:buNone/>
             </a:pPr>
             <a:r>
-              <a:rPr lang="ar-SA" altLang="en-US" sz="1200" dirty="0">
+              <a:rPr lang="ar-SA" altLang="en-US" sz="1150" dirty="0">
                 <a:solidFill>
                   <a:srgbClr val="1B2330"/>
                 </a:solidFill>
@@ -5778,26 +5778,26 @@
               </a:rPr>
               <a:t>المنصة متعددة المستأجرين: كل شركة معزولة عن الأخرى في قاعدة البيانات نفسها، والصلاحيات على مستوى المستند (الشركة، القسم، الدور).</a:t>
             </a:r>
-            <a:endParaRPr lang="ar-SA" sz="1200" dirty="0"/>
+            <a:endParaRPr lang="ar-SA" sz="1150" dirty="0"/>
           </a:p>
           <a:p>
             <a:pPr rtl="1" algn="r" indent="0" marL="0">
               <a:lnSpc>
-                <a:spcPct val="120000"/>
+                <a:spcPct val="118000"/>
               </a:lnSpc>
               <a:buNone/>
             </a:pPr>
-            <a:endParaRPr lang="ar-SA" sz="1200" dirty="0"/>
+            <a:endParaRPr lang="ar-SA" sz="1150" dirty="0"/>
           </a:p>
           <a:p>
             <a:pPr rtl="1" algn="r" indent="0" marL="0">
               <a:lnSpc>
-                <a:spcPct val="120000"/>
+                <a:spcPct val="118000"/>
               </a:lnSpc>
               <a:buNone/>
             </a:pPr>
             <a:r>
-              <a:rPr lang="ar-SA" altLang="en-US" sz="1200" dirty="0">
+              <a:rPr lang="ar-SA" altLang="en-US" sz="1150" dirty="0">
                 <a:solidFill>
                   <a:srgbClr val="1B2330"/>
                 </a:solidFill>
@@ -5805,9 +5805,9 @@
                 <a:ea typeface="Arial" pitchFamily="34" charset="-122"/>
                 <a:cs typeface="Arial" pitchFamily="34" charset="-120"/>
               </a:rPr>
-              <a:t>النشاط: تطوير وتشغيل منصة سحابية (SaaS) تُباع باشتراك شهري أو سنوي لمنشآت القطاع الخاص في المملكة.</a:t>
-            </a:r>
-            <a:endParaRPr lang="ar-SA" sz="1200" dirty="0"/>
+              <a:t>النشاط التجاري الرئيسي: تطوير وتشغيل منصة سحابية (SaaS) تُباع باشتراك شهري أو سنوي لمنشآت القطاع الخاص في المملكة. رموز التصنيف الوطني: 620113 (رئيسي)، 620102، 620111، 582001.</a:t>
+            </a:r>
+            <a:endParaRPr lang="ar-SA" sz="1150" dirty="0"/>
           </a:p>
         </p:txBody>
       </p:sp>

</xml_diff>

<commit_message>
docs(legal): show the four-phase roadmap on the deck's last slide
The two shipped phases are marked as shipped and the two planned ones
carry their customer-count trigger, so the file shows a direction
without promising an unbuilt feature. Still eight slides.

Co-Authored-By: Claude Opus 5 <noreply@anthropic.com>
Claude-Session: https://claude.ai/code/session_01D3UPL4Xh35wSLmj3NFHRuL
</commit_message>
<xml_diff>
--- a/ma3rifah-ai/docs/legal/badiha-license-deck.pptx
+++ b/ma3rifah-ai/docs/legal/badiha-license-deck.pptx
@@ -8004,7 +8004,7 @@
                 <a:ea typeface="Arial" pitchFamily="34" charset="-122"/>
                 <a:cs typeface="Arial" pitchFamily="34" charset="-120"/>
               </a:rPr>
-              <a:t>الخطوة القادمة وخطة التوسع</a:t>
+              <a:t>خارطة التطوّر وخطة التوسع</a:t>
             </a:r>
             <a:endParaRPr lang="ar-SA" sz="2600" dirty="0"/>
           </a:p>
@@ -8043,7 +8043,7 @@
                 <a:ea typeface="Arial" pitchFamily="34" charset="-122"/>
                 <a:cs typeface="Arial" pitchFamily="34" charset="-120"/>
               </a:rPr>
-              <a:t>Next feature &amp; expansion plan</a:t>
+              <a:t>Product roadmap &amp; expansion</a:t>
             </a:r>
             <a:endParaRPr lang="en-US" sz="1050" dirty="0"/>
           </a:p>
@@ -8096,12 +8096,471 @@
         </p:nvSpPr>
         <p:spPr>
           <a:xfrm>
-            <a:off x="548640" y="1143000"/>
-            <a:ext cx="8046720" cy="1572768"/>
+            <a:off x="6638544" y="1143000"/>
+            <a:ext cx="1938528" cy="658368"/>
           </a:xfrm>
           <a:prstGeom prst="roundRect">
             <a:avLst>
-              <a:gd name="adj" fmla="val 5814"/>
+              <a:gd name="adj" fmla="val 13889"/>
+            </a:avLst>
+          </a:prstGeom>
+          <a:solidFill>
+            <a:srgbClr val="1E3967"/>
+          </a:solidFill>
+          <a:ln w="12700">
+            <a:solidFill>
+              <a:srgbClr val="1E3967"/>
+            </a:solidFill>
+            <a:prstDash val="solid"/>
+          </a:ln>
+        </p:spPr>
+      </p:sp>
+      <p:sp>
+        <p:nvSpPr>
+          <p:cNvPr id="9" name="Text 7"/>
+          <p:cNvSpPr txBox="1"/>
+          <p:nvPr/>
+        </p:nvSpPr>
+        <p:spPr>
+          <a:xfrm>
+            <a:off x="6729984" y="1225296"/>
+            <a:ext cx="1755648" cy="237744"/>
+          </a:xfrm>
+          <a:prstGeom prst="rect">
+            <a:avLst/>
+          </a:prstGeom>
+          <a:noFill/>
+          <a:ln/>
+        </p:spPr>
+        <p:txBody>
+          <a:bodyPr wrap="square" lIns="0" tIns="0" rIns="0" bIns="0" rtlCol="0" anchor="t"/>
+          <a:lstStyle/>
+          <a:p>
+            <a:pPr rtl="1" algn="ctr" indent="0" marL="0">
+              <a:buNone/>
+            </a:pPr>
+            <a:r>
+              <a:rPr lang="ar-SA" altLang="en-US" sz="1000" b="1" dirty="0">
+                <a:solidFill>
+                  <a:srgbClr val="FFFFFF"/>
+                </a:solidFill>
+                <a:latin typeface="Arial" pitchFamily="34" charset="0"/>
+                <a:ea typeface="Arial" pitchFamily="34" charset="-122"/>
+                <a:cs typeface="Arial" pitchFamily="34" charset="-120"/>
+              </a:rPr>
+              <a:t>١ · اسأل · أجب · تحقّق</a:t>
+            </a:r>
+            <a:endParaRPr lang="ar-SA" sz="1000" dirty="0"/>
+          </a:p>
+        </p:txBody>
+      </p:sp>
+      <p:sp>
+        <p:nvSpPr>
+          <p:cNvPr id="10" name="Text 8"/>
+          <p:cNvSpPr txBox="1"/>
+          <p:nvPr/>
+        </p:nvSpPr>
+        <p:spPr>
+          <a:xfrm>
+            <a:off x="6729984" y="1481328"/>
+            <a:ext cx="1755648" cy="219456"/>
+          </a:xfrm>
+          <a:prstGeom prst="rect">
+            <a:avLst/>
+          </a:prstGeom>
+          <a:noFill/>
+          <a:ln/>
+        </p:spPr>
+        <p:txBody>
+          <a:bodyPr wrap="square" lIns="0" tIns="0" rIns="0" bIns="0" rtlCol="0" anchor="t"/>
+          <a:lstStyle/>
+          <a:p>
+            <a:pPr rtl="1" algn="ctr" indent="0" marL="0">
+              <a:buNone/>
+            </a:pPr>
+            <a:r>
+              <a:rPr lang="ar-SA" altLang="en-US" sz="900" b="1" dirty="0">
+                <a:solidFill>
+                  <a:srgbClr val="C9A24C"/>
+                </a:solidFill>
+                <a:latin typeface="Arial" pitchFamily="34" charset="0"/>
+                <a:ea typeface="Arial" pitchFamily="34" charset="-122"/>
+                <a:cs typeface="Arial" pitchFamily="34" charset="-120"/>
+              </a:rPr>
+              <a:t>✔ منشورة</a:t>
+            </a:r>
+            <a:endParaRPr lang="ar-SA" sz="900" dirty="0"/>
+          </a:p>
+        </p:txBody>
+      </p:sp>
+      <p:sp>
+        <p:nvSpPr>
+          <p:cNvPr id="11" name="Shape 9"/>
+          <p:cNvSpPr/>
+          <p:nvPr/>
+        </p:nvSpPr>
+        <p:spPr>
+          <a:xfrm>
+            <a:off x="4608576" y="1143000"/>
+            <a:ext cx="1938528" cy="658368"/>
+          </a:xfrm>
+          <a:prstGeom prst="roundRect">
+            <a:avLst>
+              <a:gd name="adj" fmla="val 13889"/>
+            </a:avLst>
+          </a:prstGeom>
+          <a:solidFill>
+            <a:srgbClr val="1E3967"/>
+          </a:solidFill>
+          <a:ln w="12700">
+            <a:solidFill>
+              <a:srgbClr val="1E3967"/>
+            </a:solidFill>
+            <a:prstDash val="solid"/>
+          </a:ln>
+        </p:spPr>
+      </p:sp>
+      <p:sp>
+        <p:nvSpPr>
+          <p:cNvPr id="12" name="Text 10"/>
+          <p:cNvSpPr txBox="1"/>
+          <p:nvPr/>
+        </p:nvSpPr>
+        <p:spPr>
+          <a:xfrm>
+            <a:off x="4700016" y="1225296"/>
+            <a:ext cx="1755648" cy="237744"/>
+          </a:xfrm>
+          <a:prstGeom prst="rect">
+            <a:avLst/>
+          </a:prstGeom>
+          <a:noFill/>
+          <a:ln/>
+        </p:spPr>
+        <p:txBody>
+          <a:bodyPr wrap="square" lIns="0" tIns="0" rIns="0" bIns="0" rtlCol="0" anchor="t"/>
+          <a:lstStyle/>
+          <a:p>
+            <a:pPr rtl="1" algn="ctr" indent="0" marL="0">
+              <a:buNone/>
+            </a:pPr>
+            <a:r>
+              <a:rPr lang="ar-SA" altLang="en-US" sz="1000" b="1" dirty="0">
+                <a:solidFill>
+                  <a:srgbClr val="FFFFFF"/>
+                </a:solidFill>
+                <a:latin typeface="Arial" pitchFamily="34" charset="0"/>
+                <a:ea typeface="Arial" pitchFamily="34" charset="-122"/>
+                <a:cs typeface="Arial" pitchFamily="34" charset="-120"/>
+              </a:rPr>
+              <a:t>٢ · اكتشف · وثّق · أغلق</a:t>
+            </a:r>
+            <a:endParaRPr lang="ar-SA" sz="1000" dirty="0"/>
+          </a:p>
+        </p:txBody>
+      </p:sp>
+      <p:sp>
+        <p:nvSpPr>
+          <p:cNvPr id="13" name="Text 11"/>
+          <p:cNvSpPr txBox="1"/>
+          <p:nvPr/>
+        </p:nvSpPr>
+        <p:spPr>
+          <a:xfrm>
+            <a:off x="4700016" y="1481328"/>
+            <a:ext cx="1755648" cy="219456"/>
+          </a:xfrm>
+          <a:prstGeom prst="rect">
+            <a:avLst/>
+          </a:prstGeom>
+          <a:noFill/>
+          <a:ln/>
+        </p:spPr>
+        <p:txBody>
+          <a:bodyPr wrap="square" lIns="0" tIns="0" rIns="0" bIns="0" rtlCol="0" anchor="t"/>
+          <a:lstStyle/>
+          <a:p>
+            <a:pPr rtl="1" algn="ctr" indent="0" marL="0">
+              <a:buNone/>
+            </a:pPr>
+            <a:r>
+              <a:rPr lang="ar-SA" altLang="en-US" sz="900" b="1" dirty="0">
+                <a:solidFill>
+                  <a:srgbClr val="C9A24C"/>
+                </a:solidFill>
+                <a:latin typeface="Arial" pitchFamily="34" charset="0"/>
+                <a:ea typeface="Arial" pitchFamily="34" charset="-122"/>
+                <a:cs typeface="Arial" pitchFamily="34" charset="-120"/>
+              </a:rPr>
+              <a:t>✔ منشورة</a:t>
+            </a:r>
+            <a:endParaRPr lang="ar-SA" sz="900" dirty="0"/>
+          </a:p>
+        </p:txBody>
+      </p:sp>
+      <p:sp>
+        <p:nvSpPr>
+          <p:cNvPr id="14" name="Shape 12"/>
+          <p:cNvSpPr/>
+          <p:nvPr/>
+        </p:nvSpPr>
+        <p:spPr>
+          <a:xfrm>
+            <a:off x="2578608" y="1143000"/>
+            <a:ext cx="1938528" cy="658368"/>
+          </a:xfrm>
+          <a:prstGeom prst="roundRect">
+            <a:avLst>
+              <a:gd name="adj" fmla="val 13889"/>
+            </a:avLst>
+          </a:prstGeom>
+          <a:solidFill>
+            <a:srgbClr val="FFFFFF"/>
+          </a:solidFill>
+          <a:ln w="12700">
+            <a:solidFill>
+              <a:srgbClr val="C9A24C"/>
+            </a:solidFill>
+            <a:prstDash val="solid"/>
+          </a:ln>
+        </p:spPr>
+      </p:sp>
+      <p:sp>
+        <p:nvSpPr>
+          <p:cNvPr id="15" name="Text 13"/>
+          <p:cNvSpPr txBox="1"/>
+          <p:nvPr/>
+        </p:nvSpPr>
+        <p:spPr>
+          <a:xfrm>
+            <a:off x="2670048" y="1225296"/>
+            <a:ext cx="1755648" cy="237744"/>
+          </a:xfrm>
+          <a:prstGeom prst="rect">
+            <a:avLst/>
+          </a:prstGeom>
+          <a:noFill/>
+          <a:ln/>
+        </p:spPr>
+        <p:txBody>
+          <a:bodyPr wrap="square" lIns="0" tIns="0" rIns="0" bIns="0" rtlCol="0" anchor="t"/>
+          <a:lstStyle/>
+          <a:p>
+            <a:pPr rtl="1" algn="ctr" indent="0" marL="0">
+              <a:buNone/>
+            </a:pPr>
+            <a:r>
+              <a:rPr lang="ar-SA" altLang="en-US" sz="1000" b="1" dirty="0">
+                <a:solidFill>
+                  <a:srgbClr val="1E3967"/>
+                </a:solidFill>
+                <a:latin typeface="Arial" pitchFamily="34" charset="0"/>
+                <a:ea typeface="Arial" pitchFamily="34" charset="-122"/>
+                <a:cs typeface="Arial" pitchFamily="34" charset="-120"/>
+              </a:rPr>
+              <a:t>٣ · أنشئ · راجِع · احكم</a:t>
+            </a:r>
+            <a:endParaRPr lang="ar-SA" sz="1000" dirty="0"/>
+          </a:p>
+        </p:txBody>
+      </p:sp>
+      <p:sp>
+        <p:nvSpPr>
+          <p:cNvPr id="16" name="Text 14"/>
+          <p:cNvSpPr txBox="1"/>
+          <p:nvPr/>
+        </p:nvSpPr>
+        <p:spPr>
+          <a:xfrm>
+            <a:off x="2670048" y="1481328"/>
+            <a:ext cx="1755648" cy="219456"/>
+          </a:xfrm>
+          <a:prstGeom prst="rect">
+            <a:avLst/>
+          </a:prstGeom>
+          <a:noFill/>
+          <a:ln/>
+        </p:spPr>
+        <p:txBody>
+          <a:bodyPr wrap="square" lIns="0" tIns="0" rIns="0" bIns="0" rtlCol="0" anchor="t"/>
+          <a:lstStyle/>
+          <a:p>
+            <a:pPr rtl="1" algn="ctr" indent="0" marL="0">
+              <a:buNone/>
+            </a:pPr>
+            <a:r>
+              <a:rPr lang="ar-SA" altLang="en-US" sz="900" b="1" dirty="0">
+                <a:solidFill>
+                  <a:srgbClr val="5B6573"/>
+                </a:solidFill>
+                <a:latin typeface="Arial" pitchFamily="34" charset="0"/>
+                <a:ea typeface="Arial" pitchFamily="34" charset="-122"/>
+                <a:cs typeface="Arial" pitchFamily="34" charset="-120"/>
+              </a:rPr>
+              <a:t>بعد ٣ عملاء</a:t>
+            </a:r>
+            <a:endParaRPr lang="ar-SA" sz="900" dirty="0"/>
+          </a:p>
+        </p:txBody>
+      </p:sp>
+      <p:sp>
+        <p:nvSpPr>
+          <p:cNvPr id="17" name="Shape 15"/>
+          <p:cNvSpPr/>
+          <p:nvPr/>
+        </p:nvSpPr>
+        <p:spPr>
+          <a:xfrm>
+            <a:off x="548640" y="1143000"/>
+            <a:ext cx="1938528" cy="658368"/>
+          </a:xfrm>
+          <a:prstGeom prst="roundRect">
+            <a:avLst>
+              <a:gd name="adj" fmla="val 13889"/>
+            </a:avLst>
+          </a:prstGeom>
+          <a:solidFill>
+            <a:srgbClr val="FFFFFF"/>
+          </a:solidFill>
+          <a:ln w="12700">
+            <a:solidFill>
+              <a:srgbClr val="C9A24C"/>
+            </a:solidFill>
+            <a:prstDash val="solid"/>
+          </a:ln>
+        </p:spPr>
+      </p:sp>
+      <p:sp>
+        <p:nvSpPr>
+          <p:cNvPr id="18" name="Text 16"/>
+          <p:cNvSpPr txBox="1"/>
+          <p:nvPr/>
+        </p:nvSpPr>
+        <p:spPr>
+          <a:xfrm>
+            <a:off x="640080" y="1225296"/>
+            <a:ext cx="1755648" cy="237744"/>
+          </a:xfrm>
+          <a:prstGeom prst="rect">
+            <a:avLst/>
+          </a:prstGeom>
+          <a:noFill/>
+          <a:ln/>
+        </p:spPr>
+        <p:txBody>
+          <a:bodyPr wrap="square" lIns="0" tIns="0" rIns="0" bIns="0" rtlCol="0" anchor="t"/>
+          <a:lstStyle/>
+          <a:p>
+            <a:pPr rtl="1" algn="ctr" indent="0" marL="0">
+              <a:buNone/>
+            </a:pPr>
+            <a:r>
+              <a:rPr lang="ar-SA" altLang="en-US" sz="1000" b="1" dirty="0">
+                <a:solidFill>
+                  <a:srgbClr val="1E3967"/>
+                </a:solidFill>
+                <a:latin typeface="Arial" pitchFamily="34" charset="0"/>
+                <a:ea typeface="Arial" pitchFamily="34" charset="-122"/>
+                <a:cs typeface="Arial" pitchFamily="34" charset="-120"/>
+              </a:rPr>
+              <a:t>٤ · اربط · وجّه · نفّذ</a:t>
+            </a:r>
+            <a:endParaRPr lang="ar-SA" sz="1000" dirty="0"/>
+          </a:p>
+        </p:txBody>
+      </p:sp>
+      <p:sp>
+        <p:nvSpPr>
+          <p:cNvPr id="19" name="Text 17"/>
+          <p:cNvSpPr txBox="1"/>
+          <p:nvPr/>
+        </p:nvSpPr>
+        <p:spPr>
+          <a:xfrm>
+            <a:off x="640080" y="1481328"/>
+            <a:ext cx="1755648" cy="219456"/>
+          </a:xfrm>
+          <a:prstGeom prst="rect">
+            <a:avLst/>
+          </a:prstGeom>
+          <a:noFill/>
+          <a:ln/>
+        </p:spPr>
+        <p:txBody>
+          <a:bodyPr wrap="square" lIns="0" tIns="0" rIns="0" bIns="0" rtlCol="0" anchor="t"/>
+          <a:lstStyle/>
+          <a:p>
+            <a:pPr rtl="1" algn="ctr" indent="0" marL="0">
+              <a:buNone/>
+            </a:pPr>
+            <a:r>
+              <a:rPr lang="ar-SA" altLang="en-US" sz="900" b="1" dirty="0">
+                <a:solidFill>
+                  <a:srgbClr val="5B6573"/>
+                </a:solidFill>
+                <a:latin typeface="Arial" pitchFamily="34" charset="0"/>
+                <a:ea typeface="Arial" pitchFamily="34" charset="-122"/>
+                <a:cs typeface="Arial" pitchFamily="34" charset="-120"/>
+              </a:rPr>
+              <a:t>بعد ١٥ عميلًا</a:t>
+            </a:r>
+            <a:endParaRPr lang="ar-SA" sz="900" dirty="0"/>
+          </a:p>
+        </p:txBody>
+      </p:sp>
+      <p:sp>
+        <p:nvSpPr>
+          <p:cNvPr id="20" name="Text 18"/>
+          <p:cNvSpPr txBox="1"/>
+          <p:nvPr/>
+        </p:nvSpPr>
+        <p:spPr>
+          <a:xfrm>
+            <a:off x="548640" y="1883664"/>
+            <a:ext cx="8046720" cy="256032"/>
+          </a:xfrm>
+          <a:prstGeom prst="rect">
+            <a:avLst/>
+          </a:prstGeom>
+          <a:noFill/>
+          <a:ln/>
+        </p:spPr>
+        <p:txBody>
+          <a:bodyPr wrap="square" lIns="0" tIns="0" rIns="0" bIns="0" rtlCol="0" anchor="t"/>
+          <a:lstStyle/>
+          <a:p>
+            <a:pPr rtl="1" algn="r" indent="0" marL="0">
+              <a:buNone/>
+            </a:pPr>
+            <a:r>
+              <a:rPr lang="ar-SA" altLang="en-US" sz="950" dirty="0">
+                <a:solidFill>
+                  <a:srgbClr val="5B6573"/>
+                </a:solidFill>
+                <a:latin typeface="Arial" pitchFamily="34" charset="0"/>
+                <a:ea typeface="Arial" pitchFamily="34" charset="-122"/>
+                <a:cs typeface="Arial" pitchFamily="34" charset="-120"/>
+              </a:rPr>
+              <a:t>من منصة تجيب عن المعرفة ← إلى منصة تعرف حالتها ← إلى منصة تبنيها ← إلى منصة تنفّذ بها. والمرحلتان الأوليان تعملان اليوم.</a:t>
+            </a:r>
+            <a:endParaRPr lang="ar-SA" sz="950" dirty="0"/>
+          </a:p>
+        </p:txBody>
+      </p:sp>
+      <p:sp>
+        <p:nvSpPr>
+          <p:cNvPr id="21" name="Shape 19"/>
+          <p:cNvSpPr/>
+          <p:nvPr/>
+        </p:nvSpPr>
+        <p:spPr>
+          <a:xfrm>
+            <a:off x="548640" y="2212848"/>
+            <a:ext cx="8046720" cy="841248"/>
+          </a:xfrm>
+          <a:prstGeom prst="roundRect">
+            <a:avLst>
+              <a:gd name="adj" fmla="val 10870"/>
             </a:avLst>
           </a:prstGeom>
           <a:solidFill>
@@ -8117,30 +8576,30 @@
       </p:sp>
       <p:sp>
         <p:nvSpPr>
-          <p:cNvPr id="9" name="Text 7"/>
-          <p:cNvSpPr txBox="1"/>
-          <p:nvPr/>
-        </p:nvSpPr>
-        <p:spPr>
-          <a:xfrm>
-            <a:off x="731520" y="1252728"/>
-            <a:ext cx="7680960" cy="274320"/>
-          </a:xfrm>
-          <a:prstGeom prst="rect">
-            <a:avLst/>
-          </a:prstGeom>
-          <a:noFill/>
-          <a:ln/>
-        </p:spPr>
-        <p:txBody>
-          <a:bodyPr wrap="square" lIns="0" tIns="0" rIns="0" bIns="0" rtlCol="0" anchor="t"/>
-          <a:lstStyle/>
-          <a:p>
-            <a:pPr rtl="1" algn="r" indent="0" marL="0">
-              <a:buNone/>
-            </a:pPr>
-            <a:r>
-              <a:rPr lang="ar-SA" altLang="en-US" sz="1200" b="1" dirty="0">
+          <p:cNvPr id="22" name="Text 20"/>
+          <p:cNvSpPr txBox="1"/>
+          <p:nvPr/>
+        </p:nvSpPr>
+        <p:spPr>
+          <a:xfrm>
+            <a:off x="731520" y="2304288"/>
+            <a:ext cx="7680960" cy="256032"/>
+          </a:xfrm>
+          <a:prstGeom prst="rect">
+            <a:avLst/>
+          </a:prstGeom>
+          <a:noFill/>
+          <a:ln/>
+        </p:spPr>
+        <p:txBody>
+          <a:bodyPr wrap="square" lIns="0" tIns="0" rIns="0" bIns="0" rtlCol="0" anchor="t"/>
+          <a:lstStyle/>
+          <a:p>
+            <a:pPr rtl="1" algn="r" indent="0" marL="0">
+              <a:buNone/>
+            </a:pPr>
+            <a:r>
+              <a:rPr lang="ar-SA" altLang="en-US" sz="1150" b="1" dirty="0">
                 <a:solidFill>
                   <a:srgbClr val="1E3967"/>
                 </a:solidFill>
@@ -8148,22 +8607,22 @@
                 <a:ea typeface="Arial" pitchFamily="34" charset="-122"/>
                 <a:cs typeface="Arial" pitchFamily="34" charset="-120"/>
               </a:rPr>
-              <a:t>الميزة القادمة: استوديو السياسات — مواصفة معتمدة، لم تُنشر بعد، تُبنى بعد العميل الثالث</a:t>
-            </a:r>
-            <a:endParaRPr lang="ar-SA" sz="1200" dirty="0"/>
-          </a:p>
-        </p:txBody>
-      </p:sp>
-      <p:sp>
-        <p:nvSpPr>
-          <p:cNvPr id="10" name="Text 8"/>
-          <p:cNvSpPr txBox="1"/>
-          <p:nvPr/>
-        </p:nvSpPr>
-        <p:spPr>
-          <a:xfrm>
-            <a:off x="731520" y="1572768"/>
-            <a:ext cx="7680960" cy="566928"/>
+              <a:t>الخطوة القادمة: استوديو السياسات — مواصفة معتمدة، لم تُنشر بعد</a:t>
+            </a:r>
+            <a:endParaRPr lang="ar-SA" sz="1150" dirty="0"/>
+          </a:p>
+        </p:txBody>
+      </p:sp>
+      <p:sp>
+        <p:nvSpPr>
+          <p:cNvPr id="23" name="Text 21"/>
+          <p:cNvSpPr txBox="1"/>
+          <p:nvPr/>
+        </p:nvSpPr>
+        <p:spPr>
+          <a:xfrm>
+            <a:off x="731520" y="2578608"/>
+            <a:ext cx="7680960" cy="420624"/>
           </a:xfrm>
           <a:prstGeom prst="rect">
             <a:avLst/>
@@ -8177,12 +8636,12 @@
           <a:p>
             <a:pPr rtl="1" algn="r" indent="0" marL="0">
               <a:lnSpc>
-                <a:spcPct val="114000"/>
+                <a:spcPct val="112000"/>
               </a:lnSpc>
               <a:buNone/>
             </a:pPr>
             <a:r>
-              <a:rPr lang="ar-SA" altLang="en-US" sz="980" dirty="0">
+              <a:rPr lang="ar-SA" altLang="en-US" sz="930" dirty="0">
                 <a:solidFill>
                   <a:srgbClr val="1B2330"/>
                 </a:solidFill>
@@ -8190,63 +8649,21 @@
                 <a:ea typeface="Arial" pitchFamily="34" charset="-122"/>
                 <a:cs typeface="Arial" pitchFamily="34" charset="-120"/>
               </a:rPr>
-              <a:t>مساعد يساعد الشركة على كتابة سياساتها لا الإجابة منها فقط: يسأل المدير ثلاثة إلى خمسة أسئلة توضيحية، ثم يكتب مسودة مستندة إلى وثائق الشركة وإلى مكتبة مرجعية رسمية (نظام العمل ولوائحه) مع الاستشهاد بمواد النظام؛ يحرّرها المدير ويعتمدها فتدخل قاعدة المعرفة وتُغلق الفجوة.</a:t>
-            </a:r>
-            <a:endParaRPr lang="ar-SA" sz="980" dirty="0"/>
-          </a:p>
-        </p:txBody>
-      </p:sp>
-      <p:sp>
-        <p:nvSpPr>
-          <p:cNvPr id="11" name="Text 9"/>
-          <p:cNvSpPr txBox="1"/>
-          <p:nvPr/>
-        </p:nvSpPr>
-        <p:spPr>
-          <a:xfrm>
-            <a:off x="731520" y="2212848"/>
-            <a:ext cx="7680960" cy="384048"/>
-          </a:xfrm>
-          <a:prstGeom prst="rect">
-            <a:avLst/>
-          </a:prstGeom>
-          <a:noFill/>
-          <a:ln/>
-        </p:spPr>
-        <p:txBody>
-          <a:bodyPr wrap="square" lIns="0" tIns="0" rIns="0" bIns="0" rtlCol="0" anchor="t"/>
-          <a:lstStyle/>
-          <a:p>
-            <a:pPr rtl="1" algn="r" indent="0" marL="0">
-              <a:lnSpc>
-                <a:spcPct val="114000"/>
-              </a:lnSpc>
-              <a:buNone/>
-            </a:pPr>
-            <a:r>
-              <a:rPr lang="ar-SA" altLang="en-US" sz="980" b="1" dirty="0">
-                <a:solidFill>
-                  <a:srgbClr val="1E3967"/>
-                </a:solidFill>
-                <a:latin typeface="Arial" pitchFamily="34" charset="0"/>
-                <a:ea typeface="Arial" pitchFamily="34" charset="-122"/>
-                <a:cs typeface="Arial" pitchFamily="34" charset="-120"/>
-              </a:rPr>
-              <a:t>أثرها الاستراتيجي: تقلب الاستبعاد سوقًا — الشركة بلا لوائح مستبعَدة اليوم، وبها تصير العميل المثالي. و٧٠٪ من أجزائها مبنيّ فعلًا في المنصة.</a:t>
-            </a:r>
-            <a:endParaRPr lang="ar-SA" sz="980" dirty="0"/>
-          </a:p>
-        </p:txBody>
-      </p:sp>
-      <p:sp>
-        <p:nvSpPr>
-          <p:cNvPr id="12" name="Shape 10"/>
+              <a:t>يكتب مسودة سياسة من وثائق الشركة ومن مكتبة مرجعية رسمية مع الاستشهاد بمواد النظام، يعتمدها المدير فتدخل قاعدة المعرفة. أثرها: تقلب الاستبعاد سوقًا — الشركة بلا لوائح تصير العميل المثالي، و٧٠٪ من أجزائها مبنيّ فعلًا.</a:t>
+            </a:r>
+            <a:endParaRPr lang="ar-SA" sz="930" dirty="0"/>
+          </a:p>
+        </p:txBody>
+      </p:sp>
+      <p:sp>
+        <p:nvSpPr>
+          <p:cNvPr id="24" name="Shape 22"/>
           <p:cNvSpPr/>
           <p:nvPr/>
         </p:nvSpPr>
         <p:spPr>
           <a:xfrm>
-            <a:off x="1097280" y="3383280"/>
+            <a:off x="1097280" y="3584448"/>
             <a:ext cx="6949440" cy="0"/>
           </a:xfrm>
           <a:prstGeom prst="line">
@@ -8263,13 +8680,13 @@
       </p:sp>
       <p:sp>
         <p:nvSpPr>
-          <p:cNvPr id="13" name="Shape 11"/>
+          <p:cNvPr id="25" name="Shape 23"/>
           <p:cNvSpPr/>
           <p:nvPr/>
         </p:nvSpPr>
         <p:spPr>
           <a:xfrm>
-            <a:off x="7132320" y="3200400"/>
+            <a:off x="7132320" y="3401568"/>
             <a:ext cx="365760" cy="365760"/>
           </a:xfrm>
           <a:prstGeom prst="ellipse">
@@ -8288,14 +8705,14 @@
       </p:sp>
       <p:sp>
         <p:nvSpPr>
-          <p:cNvPr id="14" name="Text 12"/>
-          <p:cNvSpPr txBox="1"/>
-          <p:nvPr/>
-        </p:nvSpPr>
-        <p:spPr>
-          <a:xfrm>
-            <a:off x="6035040" y="2880360"/>
-            <a:ext cx="2560320" cy="256032"/>
+          <p:cNvPr id="26" name="Text 24"/>
+          <p:cNvSpPr txBox="1"/>
+          <p:nvPr/>
+        </p:nvSpPr>
+        <p:spPr>
+          <a:xfrm>
+            <a:off x="6035040" y="3145536"/>
+            <a:ext cx="2560320" cy="237744"/>
           </a:xfrm>
           <a:prstGeom prst="rect">
             <a:avLst/>
@@ -8311,7 +8728,7 @@
               <a:buNone/>
             </a:pPr>
             <a:r>
-              <a:rPr lang="ar-SA" altLang="en-US" sz="950" dirty="0">
+              <a:rPr lang="ar-SA" altLang="en-US" sz="900" dirty="0">
                 <a:solidFill>
                   <a:srgbClr val="5B6573"/>
                 </a:solidFill>
@@ -8321,20 +8738,20 @@
               </a:rPr>
               <a:t>السنوات ١ إلى ٣</a:t>
             </a:r>
-            <a:endParaRPr lang="ar-SA" sz="950" dirty="0"/>
-          </a:p>
-        </p:txBody>
-      </p:sp>
-      <p:sp>
-        <p:nvSpPr>
-          <p:cNvPr id="15" name="Text 13"/>
-          <p:cNvSpPr txBox="1"/>
-          <p:nvPr/>
-        </p:nvSpPr>
-        <p:spPr>
-          <a:xfrm>
-            <a:off x="6035040" y="3703320"/>
-            <a:ext cx="2560320" cy="310896"/>
+            <a:endParaRPr lang="ar-SA" sz="900" dirty="0"/>
+          </a:p>
+        </p:txBody>
+      </p:sp>
+      <p:sp>
+        <p:nvSpPr>
+          <p:cNvPr id="27" name="Text 25"/>
+          <p:cNvSpPr txBox="1"/>
+          <p:nvPr/>
+        </p:nvSpPr>
+        <p:spPr>
+          <a:xfrm>
+            <a:off x="6035040" y="3886200"/>
+            <a:ext cx="2560320" cy="292608"/>
           </a:xfrm>
           <a:prstGeom prst="rect">
             <a:avLst/>
@@ -8350,7 +8767,7 @@
               <a:buNone/>
             </a:pPr>
             <a:r>
-              <a:rPr lang="ar-SA" altLang="en-US" sz="1400" b="1" dirty="0">
+              <a:rPr lang="ar-SA" altLang="en-US" sz="1350" b="1" dirty="0">
                 <a:solidFill>
                   <a:srgbClr val="1E3967"/>
                 </a:solidFill>
@@ -8360,20 +8777,20 @@
               </a:rPr>
               <a:t>داخل المملكة</a:t>
             </a:r>
-            <a:endParaRPr lang="ar-SA" sz="1400" dirty="0"/>
-          </a:p>
-        </p:txBody>
-      </p:sp>
-      <p:sp>
-        <p:nvSpPr>
-          <p:cNvPr id="16" name="Text 14"/>
-          <p:cNvSpPr txBox="1"/>
-          <p:nvPr/>
-        </p:nvSpPr>
-        <p:spPr>
-          <a:xfrm>
-            <a:off x="6126480" y="4041648"/>
-            <a:ext cx="2377440" cy="822960"/>
+            <a:endParaRPr lang="ar-SA" sz="1350" dirty="0"/>
+          </a:p>
+        </p:txBody>
+      </p:sp>
+      <p:sp>
+        <p:nvSpPr>
+          <p:cNvPr id="28" name="Text 26"/>
+          <p:cNvSpPr txBox="1"/>
+          <p:nvPr/>
+        </p:nvSpPr>
+        <p:spPr>
+          <a:xfrm>
+            <a:off x="6126480" y="4206240"/>
+            <a:ext cx="2377440" cy="658368"/>
           </a:xfrm>
           <a:prstGeom prst="rect">
             <a:avLst/>
@@ -8387,12 +8804,12 @@
           <a:p>
             <a:pPr rtl="1" algn="r" indent="0" marL="0">
               <a:lnSpc>
-                <a:spcPct val="112000"/>
+                <a:spcPct val="110000"/>
               </a:lnSpc>
               <a:buNone/>
             </a:pPr>
             <a:r>
-              <a:rPr lang="ar-SA" altLang="en-US" sz="900" dirty="0">
+              <a:rPr lang="ar-SA" altLang="en-US" sz="860" dirty="0">
                 <a:solidFill>
                   <a:srgbClr val="1B2330"/>
                 </a:solidFill>
@@ -8402,19 +8819,19 @@
               </a:rPr>
               <a:t>الرياض ثم جدة والدمام. بيع مباشر وقناة شركاء، وبناء المراجع والشهادة الأمنية. المنشأة والفريق والاستضافة والعملاء داخل المملكة.</a:t>
             </a:r>
-            <a:endParaRPr lang="ar-SA" sz="900" dirty="0"/>
-          </a:p>
-        </p:txBody>
-      </p:sp>
-      <p:sp>
-        <p:nvSpPr>
-          <p:cNvPr id="17" name="Shape 15"/>
+            <a:endParaRPr lang="ar-SA" sz="860" dirty="0"/>
+          </a:p>
+        </p:txBody>
+      </p:sp>
+      <p:sp>
+        <p:nvSpPr>
+          <p:cNvPr id="29" name="Shape 27"/>
           <p:cNvSpPr/>
           <p:nvPr/>
         </p:nvSpPr>
         <p:spPr>
           <a:xfrm>
-            <a:off x="4389120" y="3200400"/>
+            <a:off x="4389120" y="3401568"/>
             <a:ext cx="365760" cy="365760"/>
           </a:xfrm>
           <a:prstGeom prst="ellipse">
@@ -8433,14 +8850,14 @@
       </p:sp>
       <p:sp>
         <p:nvSpPr>
-          <p:cNvPr id="18" name="Text 16"/>
-          <p:cNvSpPr txBox="1"/>
-          <p:nvPr/>
-        </p:nvSpPr>
-        <p:spPr>
-          <a:xfrm>
-            <a:off x="3291840" y="2880360"/>
-            <a:ext cx="2560320" cy="256032"/>
+          <p:cNvPr id="30" name="Text 28"/>
+          <p:cNvSpPr txBox="1"/>
+          <p:nvPr/>
+        </p:nvSpPr>
+        <p:spPr>
+          <a:xfrm>
+            <a:off x="3291840" y="3145536"/>
+            <a:ext cx="2560320" cy="237744"/>
           </a:xfrm>
           <a:prstGeom prst="rect">
             <a:avLst/>
@@ -8456,7 +8873,7 @@
               <a:buNone/>
             </a:pPr>
             <a:r>
-              <a:rPr lang="ar-SA" altLang="en-US" sz="950" dirty="0">
+              <a:rPr lang="ar-SA" altLang="en-US" sz="900" dirty="0">
                 <a:solidFill>
                   <a:srgbClr val="5B6573"/>
                 </a:solidFill>
@@ -8466,20 +8883,20 @@
               </a:rPr>
               <a:t>السنتان ٤ و٥</a:t>
             </a:r>
-            <a:endParaRPr lang="ar-SA" sz="950" dirty="0"/>
-          </a:p>
-        </p:txBody>
-      </p:sp>
-      <p:sp>
-        <p:nvSpPr>
-          <p:cNvPr id="19" name="Text 17"/>
-          <p:cNvSpPr txBox="1"/>
-          <p:nvPr/>
-        </p:nvSpPr>
-        <p:spPr>
-          <a:xfrm>
-            <a:off x="3291840" y="3703320"/>
-            <a:ext cx="2560320" cy="310896"/>
+            <a:endParaRPr lang="ar-SA" sz="900" dirty="0"/>
+          </a:p>
+        </p:txBody>
+      </p:sp>
+      <p:sp>
+        <p:nvSpPr>
+          <p:cNvPr id="31" name="Text 29"/>
+          <p:cNvSpPr txBox="1"/>
+          <p:nvPr/>
+        </p:nvSpPr>
+        <p:spPr>
+          <a:xfrm>
+            <a:off x="3291840" y="3886200"/>
+            <a:ext cx="2560320" cy="292608"/>
           </a:xfrm>
           <a:prstGeom prst="rect">
             <a:avLst/>
@@ -8495,7 +8912,7 @@
               <a:buNone/>
             </a:pPr>
             <a:r>
-              <a:rPr lang="ar-SA" altLang="en-US" sz="1400" b="1" dirty="0">
+              <a:rPr lang="ar-SA" altLang="en-US" sz="1350" b="1" dirty="0">
                 <a:solidFill>
                   <a:srgbClr val="1E3967"/>
                 </a:solidFill>
@@ -8505,20 +8922,20 @@
               </a:rPr>
               <a:t>دول الخليج</a:t>
             </a:r>
-            <a:endParaRPr lang="ar-SA" sz="1400" dirty="0"/>
-          </a:p>
-        </p:txBody>
-      </p:sp>
-      <p:sp>
-        <p:nvSpPr>
-          <p:cNvPr id="20" name="Text 18"/>
-          <p:cNvSpPr txBox="1"/>
-          <p:nvPr/>
-        </p:nvSpPr>
-        <p:spPr>
-          <a:xfrm>
-            <a:off x="3383280" y="4041648"/>
-            <a:ext cx="2377440" cy="822960"/>
+            <a:endParaRPr lang="ar-SA" sz="1350" dirty="0"/>
+          </a:p>
+        </p:txBody>
+      </p:sp>
+      <p:sp>
+        <p:nvSpPr>
+          <p:cNvPr id="32" name="Text 30"/>
+          <p:cNvSpPr txBox="1"/>
+          <p:nvPr/>
+        </p:nvSpPr>
+        <p:spPr>
+          <a:xfrm>
+            <a:off x="3383280" y="4206240"/>
+            <a:ext cx="2377440" cy="658368"/>
           </a:xfrm>
           <a:prstGeom prst="rect">
             <a:avLst/>
@@ -8532,12 +8949,12 @@
           <a:p>
             <a:pPr rtl="1" algn="r" indent="0" marL="0">
               <a:lnSpc>
-                <a:spcPct val="112000"/>
+                <a:spcPct val="110000"/>
               </a:lnSpc>
               <a:buNone/>
             </a:pPr>
             <a:r>
-              <a:rPr lang="ar-SA" altLang="en-US" sz="900" dirty="0">
+              <a:rPr lang="ar-SA" altLang="en-US" sz="860" dirty="0">
                 <a:solidFill>
                   <a:srgbClr val="1B2330"/>
                 </a:solidFill>
@@ -8547,19 +8964,19 @@
               </a:rPr>
               <a:t>الإمارات وقطر والكويت عبر شركاء محليين، بالمنتج نفسه واللغة نفسها، مع خيار استضافة إقليمية.</a:t>
             </a:r>
-            <a:endParaRPr lang="ar-SA" sz="900" dirty="0"/>
-          </a:p>
-        </p:txBody>
-      </p:sp>
-      <p:sp>
-        <p:nvSpPr>
-          <p:cNvPr id="21" name="Shape 19"/>
+            <a:endParaRPr lang="ar-SA" sz="860" dirty="0"/>
+          </a:p>
+        </p:txBody>
+      </p:sp>
+      <p:sp>
+        <p:nvSpPr>
+          <p:cNvPr id="33" name="Shape 31"/>
           <p:cNvSpPr/>
           <p:nvPr/>
         </p:nvSpPr>
         <p:spPr>
           <a:xfrm>
-            <a:off x="1645920" y="3200400"/>
+            <a:off x="1645920" y="3401568"/>
             <a:ext cx="365760" cy="365760"/>
           </a:xfrm>
           <a:prstGeom prst="ellipse">
@@ -8578,14 +8995,14 @@
       </p:sp>
       <p:sp>
         <p:nvSpPr>
-          <p:cNvPr id="22" name="Text 20"/>
-          <p:cNvSpPr txBox="1"/>
-          <p:nvPr/>
-        </p:nvSpPr>
-        <p:spPr>
-          <a:xfrm>
-            <a:off x="548640" y="2880360"/>
-            <a:ext cx="2560320" cy="256032"/>
+          <p:cNvPr id="34" name="Text 32"/>
+          <p:cNvSpPr txBox="1"/>
+          <p:nvPr/>
+        </p:nvSpPr>
+        <p:spPr>
+          <a:xfrm>
+            <a:off x="548640" y="3145536"/>
+            <a:ext cx="2560320" cy="237744"/>
           </a:xfrm>
           <a:prstGeom prst="rect">
             <a:avLst/>
@@ -8601,7 +9018,7 @@
               <a:buNone/>
             </a:pPr>
             <a:r>
-              <a:rPr lang="ar-SA" altLang="en-US" sz="950" dirty="0">
+              <a:rPr lang="ar-SA" altLang="en-US" sz="900" dirty="0">
                 <a:solidFill>
                   <a:srgbClr val="5B6573"/>
                 </a:solidFill>
@@ -8611,20 +9028,20 @@
               </a:rPr>
               <a:t>بعد السنة ٥</a:t>
             </a:r>
-            <a:endParaRPr lang="ar-SA" sz="950" dirty="0"/>
-          </a:p>
-        </p:txBody>
-      </p:sp>
-      <p:sp>
-        <p:nvSpPr>
-          <p:cNvPr id="23" name="Text 21"/>
-          <p:cNvSpPr txBox="1"/>
-          <p:nvPr/>
-        </p:nvSpPr>
-        <p:spPr>
-          <a:xfrm>
-            <a:off x="548640" y="3703320"/>
-            <a:ext cx="2560320" cy="310896"/>
+            <a:endParaRPr lang="ar-SA" sz="900" dirty="0"/>
+          </a:p>
+        </p:txBody>
+      </p:sp>
+      <p:sp>
+        <p:nvSpPr>
+          <p:cNvPr id="35" name="Text 33"/>
+          <p:cNvSpPr txBox="1"/>
+          <p:nvPr/>
+        </p:nvSpPr>
+        <p:spPr>
+          <a:xfrm>
+            <a:off x="548640" y="3886200"/>
+            <a:ext cx="2560320" cy="292608"/>
           </a:xfrm>
           <a:prstGeom prst="rect">
             <a:avLst/>
@@ -8640,7 +9057,7 @@
               <a:buNone/>
             </a:pPr>
             <a:r>
-              <a:rPr lang="ar-SA" altLang="en-US" sz="1400" b="1" dirty="0">
+              <a:rPr lang="ar-SA" altLang="en-US" sz="1350" b="1" dirty="0">
                 <a:solidFill>
                   <a:srgbClr val="1E3967"/>
                 </a:solidFill>
@@ -8650,20 +9067,20 @@
               </a:rPr>
               <a:t>الأسواق الناطقة بالعربية</a:t>
             </a:r>
-            <a:endParaRPr lang="ar-SA" sz="1400" dirty="0"/>
-          </a:p>
-        </p:txBody>
-      </p:sp>
-      <p:sp>
-        <p:nvSpPr>
-          <p:cNvPr id="24" name="Text 22"/>
-          <p:cNvSpPr txBox="1"/>
-          <p:nvPr/>
-        </p:nvSpPr>
-        <p:spPr>
-          <a:xfrm>
-            <a:off x="640080" y="4041648"/>
-            <a:ext cx="2377440" cy="822960"/>
+            <a:endParaRPr lang="ar-SA" sz="1350" dirty="0"/>
+          </a:p>
+        </p:txBody>
+      </p:sp>
+      <p:sp>
+        <p:nvSpPr>
+          <p:cNvPr id="36" name="Text 34"/>
+          <p:cNvSpPr txBox="1"/>
+          <p:nvPr/>
+        </p:nvSpPr>
+        <p:spPr>
+          <a:xfrm>
+            <a:off x="640080" y="4206240"/>
+            <a:ext cx="2377440" cy="658368"/>
           </a:xfrm>
           <a:prstGeom prst="rect">
             <a:avLst/>
@@ -8677,12 +9094,12 @@
           <a:p>
             <a:pPr rtl="1" algn="r" indent="0" marL="0">
               <a:lnSpc>
-                <a:spcPct val="112000"/>
+                <a:spcPct val="110000"/>
               </a:lnSpc>
               <a:buNone/>
             </a:pPr>
             <a:r>
-              <a:rPr lang="ar-SA" altLang="en-US" sz="900" dirty="0">
+              <a:rPr lang="ar-SA" altLang="en-US" sz="860" dirty="0">
                 <a:solidFill>
                   <a:srgbClr val="1B2330"/>
                 </a:solidFill>
@@ -8692,7 +9109,7 @@
               </a:rPr>
               <a:t>مصر والأردن والمغرب العربي، حيث لا يوجد بديل عربي أولًا وبمعايير أمان مبنية للمؤسسات.</a:t>
             </a:r>
-            <a:endParaRPr lang="ar-SA" sz="900" dirty="0"/>
+            <a:endParaRPr lang="ar-SA" sz="860" dirty="0"/>
           </a:p>
         </p:txBody>
       </p:sp>

</xml_diff>